<commit_message>
feat: enhance stock chart visuals with hi-low lines and up-down bars
</commit_message>
<xml_diff>
--- a/smoke_samples/family4_stock_combo.pptx
+++ b/smoke_samples/family4_stock_combo.pptx
@@ -145,6 +145,9 @@
             </c:numLit>
           </c:val>
         </c:ser>
+        <c:hiLowLines>
+          <c:spPr/>
+        </c:hiLowLines>
         <c:axId val="48650112"/>
         <c:axId val="48672768"/>
       </c:stockChart>
@@ -353,6 +356,18 @@
             </c:numLit>
           </c:val>
         </c:ser>
+        <c:hiLowLines>
+          <c:spPr/>
+        </c:hiLowLines>
+        <c:upDownBars>
+          <c:gapWidth val="150"/>
+          <c:upBars>
+            <c:spPr/>
+          </c:upBars>
+          <c:downBars>
+            <c:spPr/>
+          </c:downBars>
+        </c:upDownBars>
         <c:axId val="48650112"/>
         <c:axId val="48672768"/>
       </c:stockChart>

</xml_diff>